<commit_message>
updated contributions section in status ppt
</commit_message>
<xml_diff>
--- a/team/status_update.pptx
+++ b/team/status_update.pptx
@@ -4421,7 +4421,7 @@
                   <a:srgbClr val="2E6F95"/>
                 </a:solidFill>
               </a:rPr>
-              <a:t>Rishabh — no new commits this window</a:t>
+              <a:t>Rishabh — supported this review, no new solo commits</a:t>
             </a:r>
           </a:p>
         </p:txBody>
@@ -4435,7 +4435,7 @@
         <p:spPr>
           <a:xfrm>
             <a:off x="6309360" y="4754880"/>
-            <a:ext cx="5394960" cy="1280160"/>
+            <a:ext cx="5394960" cy="1463040"/>
           </a:xfrm>
           <a:prstGeom prst="rect">
             <a:avLst/>
@@ -4468,6 +4468,29 @@
                 </a:solidFill>
               </a:rPr>
               <a:t>07/03 — data loader, CHV module, EDA visualizations, Intro/Data/Related-Work sections</a:t>
+            </a:r>
+          </a:p>
+          <a:p>
+            <a:pPr>
+              <a:spcAft>
+                <a:spcPts val="600"/>
+              </a:spcAft>
+            </a:pPr>
+            <a:r>
+              <a:rPr sz="1250" b="1">
+                <a:solidFill>
+                  <a:srgbClr val="1E7B4D"/>
+                </a:solidFill>
+              </a:rPr>
+              <a:t>• This window: </a:t>
+            </a:r>
+            <a:r>
+              <a:rPr sz="1250">
+                <a:solidFill>
+                  <a:srgbClr val="1F2A44"/>
+                </a:solidFill>
+              </a:rPr>
+              <a:t>contributed alongside Sruthilaya on reviewing/cross-checking teammates' results this pass</a:t>
             </a:r>
           </a:p>
           <a:p>

</xml_diff>